<commit_message>
Fix a title overflow on the deck's key slide, refresh its counts
Estimated rendered text height against box height for every text frame and
found one real overflow: slide 6's title ("The attacker pays 5.3x. The victim
pays nothing extra.") is 53 characters at 34pt, needing ~12.5in in an 11.9in
box. It wraps to two lines and pushes into the subtitle beneath it — on the one
slide the whole argument rests on.

Shortened to "Attacker pays 5.3x. Victim pays nothing extra." — same claim, one
line. Also grew the slide 3 layer descriptions from 0.45in to 0.55in, which were
at 0.96 of their box, and updated the headline stats to 247 tests / 12.8 KB.

No frame now exceeds its box; the tightest sits at 0.91. This is an estimate
(average glyph width, +/-20%) rather than a render — LibreOffice is not
available here — so a visual pass is still worth two minutes.

Co-Authored-By: Claude Opus 4.6 <noreply@anthropic.com>
</commit_message>
<xml_diff>
--- a/GradientShield-Demo.pptx
+++ b/GradientShield-Demo.pptx
@@ -799,7 +799,7 @@
           <a:p>
             <a:r>
               <a:rPr lang="en-US" dirty="0"/>
-              <a:t>GradientShield is a Uniswap v4 hook that makes MEV extraction unprofitable. The headline framing matters: we do not block trades and we do not claim to give the victim their price back. We make the attacker pay, measurably, while leaving honest traders exactly where an ordinary pool would leave them. 245 tests, and a live loop you can run on anvil.</a:t>
+              <a:t>GradientShield is a Uniswap v4 hook that makes MEV extraction unprofitable. The headline framing matters: we do not block trades and we do not claim to give the victim their price back. We make the attacker pay, measurably, while leaving honest traders exactly where an ordinary pool would leave them. 247 tests, and a live loop you can run on anvil.</a:t>
             </a:r>
             <a:endParaRPr lang="en-US" dirty="0"/>
           </a:p>
@@ -2029,7 +2029,7 @@
                 <a:ea typeface="Arial" pitchFamily="34" charset="-122"/>
                 <a:cs typeface="Arial" pitchFamily="34" charset="-120"/>
               </a:rPr>
-              <a:t>245</a:t>
+              <a:t>247</a:t>
             </a:r>
             <a:endParaRPr lang="en-US" sz="2600" dirty="0"/>
           </a:p>
@@ -2107,7 +2107,7 @@
                 <a:ea typeface="Arial" pitchFamily="34" charset="-122"/>
                 <a:cs typeface="Arial" pitchFamily="34" charset="-120"/>
               </a:rPr>
-              <a:t>12.7 KB</a:t>
+              <a:t>12.8 KB</a:t>
             </a:r>
             <a:endParaRPr lang="en-US" sz="2600" dirty="0"/>
           </a:p>
@@ -3334,7 +3334,7 @@
         <p:spPr>
           <a:xfrm>
             <a:off x="4297680" y="2057400"/>
-            <a:ext cx="6903720" cy="411480"/>
+            <a:ext cx="6903720" cy="502920"/>
           </a:xfrm>
           <a:prstGeom prst="rect">
             <a:avLst/>
@@ -3542,7 +3542,7 @@
         <p:spPr>
           <a:xfrm>
             <a:off x="4297680" y="2898648"/>
-            <a:ext cx="6903720" cy="411480"/>
+            <a:ext cx="6903720" cy="502920"/>
           </a:xfrm>
           <a:prstGeom prst="rect">
             <a:avLst/>
@@ -3750,7 +3750,7 @@
         <p:spPr>
           <a:xfrm>
             <a:off x="4297680" y="3739896"/>
-            <a:ext cx="6903720" cy="411480"/>
+            <a:ext cx="6903720" cy="502920"/>
           </a:xfrm>
           <a:prstGeom prst="rect">
             <a:avLst/>
@@ -3958,7 +3958,7 @@
         <p:spPr>
           <a:xfrm>
             <a:off x="4297680" y="4581144"/>
-            <a:ext cx="6903720" cy="411480"/>
+            <a:ext cx="6903720" cy="502920"/>
           </a:xfrm>
           <a:prstGeom prst="rect">
             <a:avLst/>
@@ -4166,7 +4166,7 @@
         <p:spPr>
           <a:xfrm>
             <a:off x="4297680" y="5422392"/>
-            <a:ext cx="6903720" cy="411480"/>
+            <a:ext cx="6903720" cy="502920"/>
           </a:xfrm>
           <a:prstGeom prst="rect">
             <a:avLst/>
@@ -5857,7 +5857,7 @@
                 <a:ea typeface="Arial" pitchFamily="34" charset="-122"/>
                 <a:cs typeface="Arial" pitchFamily="34" charset="-120"/>
               </a:rPr>
-              <a:t>The attacker pays 5.3x. The victim pays nothing extra.</a:t>
+              <a:t>Attacker pays 5.3x. Victim pays nothing extra.</a:t>
             </a:r>
             <a:endParaRPr lang="en-US" sz="3400" dirty="0"/>
           </a:p>
@@ -9356,7 +9356,7 @@
                 <a:ea typeface="Arial" pitchFamily="34" charset="-122"/>
                 <a:cs typeface="Arial" pitchFamily="34" charset="-120"/>
               </a:rPr>
-              <a:t>245</a:t>
+              <a:t>247</a:t>
             </a:r>
             <a:endParaRPr lang="en-US" sz="2200" dirty="0"/>
           </a:p>

</xml_diff>

<commit_message>
Add a submission slide, and a LICENSE so its claim holds
Slide 10 closes the deck with what a judge acts on: the repository, the single
command that proves it (clone + forge test, 247 passing, no setup), what is in
the box, and both halves of the theme — MEV protection, and sustainable
liquidity via the escalated fee being an LP fee.

The slide says "MIT licensed". Every source file carried the SPDX header but the
repo had no LICENSE file, so GitHub reported it as unlicensed and the claim
would not have checked out. Added the MIT text.

Deck: 10 slides, validation passes, no frame exceeds its box (tightest 0.91).

Co-Authored-By: Claude Opus 4.6 <noreply@anthropic.com>
</commit_message>
<xml_diff>
--- a/GradientShield-Demo.pptx
+++ b/GradientShield-Demo.pptx
@@ -14,9 +14,10 @@
     <p:sldId id="262" r:id="rId8"/>
     <p:sldId id="263" r:id="rId9"/>
     <p:sldId id="264" r:id="rId10"/>
+    <p:sldId id="265" r:id="rId11"/>
   </p:sldIdLst>
   <p:notesMasterIdLst>
-    <p:notesMasterId r:id="rId11"/>
+    <p:notesMasterId r:id="rId12"/>
   </p:notesMasterIdLst>
   <p:sldSz cx="12192000" cy="6858000"/>
   <p:notesSz cx="6858000" cy="12192000"/>
@@ -823,6 +824,94 @@
             <a:fld id="{F7021451-1387-4CA6-816F-3879F97B5CBC}" type="slidenum">
               <a:rPr lang="en-US"/>
               <a:t>1</a:t>
+            </a:fld>
+            <a:endParaRPr lang="en-US"/>
+          </a:p>
+        </p:txBody>
+      </p:sp>
+    </p:spTree>
+    <p:extLst>
+      <p:ext uri="{BB962C8B-B14F-4D97-AF65-F5344CB8AC3E}">
+        <p14:creationId xmlns:p14="http://schemas.microsoft.com/office/powerpoint/2010/main" val="1024086991"/>
+      </p:ext>
+    </p:extLst>
+  </p:cSld>
+  <p:clrMapOvr>
+    <a:masterClrMapping/>
+  </p:clrMapOvr>
+</p:notes>
+</file>
+
+<file path=ppt/notesSlides/notesSlide10.xml><?xml version="1.0" encoding="utf-8"?>
+<p:notes xmlns:a="http://schemas.openxmlformats.org/drawingml/2006/main" xmlns:r="http://schemas.openxmlformats.org/officeDocument/2006/relationships" xmlns:p="http://schemas.openxmlformats.org/presentationml/2006/main">
+  <p:cSld>
+    <p:spTree>
+      <p:nvGrpSpPr>
+        <p:cNvPr id="1" name=""/>
+        <p:cNvGrpSpPr/>
+        <p:nvPr/>
+      </p:nvGrpSpPr>
+      <p:grpSpPr>
+        <a:xfrm>
+          <a:off x="0" y="0"/>
+          <a:ext cx="0" cy="0"/>
+          <a:chOff x="0" y="0"/>
+          <a:chExt cx="0" cy="0"/>
+        </a:xfrm>
+      </p:grpSpPr>
+      <p:sp>
+        <p:nvSpPr>
+          <p:cNvPr id="2" name="Slide Image Placeholder 1"/>
+          <p:cNvSpPr>
+            <a:spLocks noGrp="1" noRot="1" noChangeAspect="1"/>
+          </p:cNvSpPr>
+          <p:nvPr>
+            <p:ph type="sldImg"/>
+          </p:nvPr>
+        </p:nvSpPr>
+        <p:spPr/>
+      </p:sp>
+      <p:sp>
+        <p:nvSpPr>
+          <p:cNvPr id="3" name="Notes Placeholder 2"/>
+          <p:cNvSpPr>
+            <a:spLocks noGrp="1"/>
+          </p:cNvSpPr>
+          <p:nvPr>
+            <p:ph type="body" idx="1"/>
+          </p:nvPr>
+        </p:nvSpPr>
+        <p:spPr/>
+        <p:txBody>
+          <a:bodyPr/>
+          <a:lstStyle/>
+          <a:p>
+            <a:r>
+              <a:rPr lang="en-US" dirty="0"/>
+              <a:t>Closing slide. Everything a judge needs to act on: the repository, and the one command that proves it — clone and forge test, 247 passing with no setup. Both halves of the theme are covered: MEV protection is the obvious one, and sustainable liquidity because the escalated fee is an LP fee, so what the attacker does extract is redirected into yield for the liquidity providers they were preying on.</a:t>
+            </a:r>
+            <a:endParaRPr lang="en-US" dirty="0"/>
+          </a:p>
+        </p:txBody>
+      </p:sp>
+      <p:sp>
+        <p:nvSpPr>
+          <p:cNvPr id="4" name="Slide Number Placeholder 3"/>
+          <p:cNvSpPr>
+            <a:spLocks noGrp="1"/>
+          </p:cNvSpPr>
+          <p:nvPr>
+            <p:ph type="sldNum" sz="quarter" idx="10"/>
+          </p:nvPr>
+        </p:nvSpPr>
+        <p:spPr/>
+        <p:txBody>
+          <a:bodyPr/>
+          <a:lstStyle/>
+          <a:p>
+            <a:fld id="{F7021451-1387-4CA6-816F-3879F97B5CBC}" type="slidenum">
+              <a:rPr lang="en-US"/>
+              <a:t>10</a:t>
             </a:fld>
             <a:endParaRPr lang="en-US"/>
           </a:p>
@@ -2277,6 +2366,916 @@
 </p:sld>
 </file>
 
+<file path=ppt/slides/slide10.xml><?xml version="1.0" encoding="utf-8"?>
+<p:sld xmlns:a="http://schemas.openxmlformats.org/drawingml/2006/main" xmlns:r="http://schemas.openxmlformats.org/officeDocument/2006/relationships" xmlns:p="http://schemas.openxmlformats.org/presentationml/2006/main">
+  <p:cSld name="Slide 10">
+    <p:bg>
+      <p:bgPr>
+        <a:solidFill>
+          <a:srgbClr val="0F1922"/>
+        </a:solidFill>
+      </p:bgPr>
+    </p:bg>
+    <p:spTree>
+      <p:nvGrpSpPr>
+        <p:cNvPr id="1" name=""/>
+        <p:cNvGrpSpPr/>
+        <p:nvPr/>
+      </p:nvGrpSpPr>
+      <p:grpSpPr>
+        <a:xfrm>
+          <a:off x="0" y="0"/>
+          <a:ext cx="0" cy="0"/>
+          <a:chOff x="0" y="0"/>
+          <a:chExt cx="0" cy="0"/>
+        </a:xfrm>
+      </p:grpSpPr>
+      <p:sp>
+        <p:nvSpPr>
+          <p:cNvPr id="2" name="Text 0"/>
+          <p:cNvSpPr txBox="1"/>
+          <p:nvPr/>
+        </p:nvSpPr>
+        <p:spPr>
+          <a:xfrm>
+            <a:off x="640080" y="685800"/>
+            <a:ext cx="8686800" cy="777240"/>
+          </a:xfrm>
+          <a:prstGeom prst="rect">
+            <a:avLst/>
+          </a:prstGeom>
+          <a:noFill/>
+          <a:ln/>
+        </p:spPr>
+        <p:txBody>
+          <a:bodyPr wrap="square" lIns="0" tIns="0" rIns="0" bIns="0" rtlCol="0" anchor="ctr"/>
+          <a:lstStyle/>
+          <a:p>
+            <a:pPr indent="0" marL="0">
+              <a:buNone/>
+            </a:pPr>
+            <a:r>
+              <a:rPr lang="en-US" sz="4200" b="1" dirty="0">
+                <a:solidFill>
+                  <a:srgbClr val="EAF2F6"/>
+                </a:solidFill>
+                <a:latin typeface="Arial" pitchFamily="34" charset="0"/>
+                <a:ea typeface="Arial" pitchFamily="34" charset="-122"/>
+                <a:cs typeface="Arial" pitchFamily="34" charset="-120"/>
+              </a:rPr>
+              <a:t>GradientShield</a:t>
+            </a:r>
+            <a:endParaRPr lang="en-US" sz="4200" dirty="0"/>
+          </a:p>
+        </p:txBody>
+      </p:sp>
+      <p:sp>
+        <p:nvSpPr>
+          <p:cNvPr id="3" name="Text 1"/>
+          <p:cNvSpPr txBox="1"/>
+          <p:nvPr/>
+        </p:nvSpPr>
+        <p:spPr>
+          <a:xfrm>
+            <a:off x="640080" y="1463040"/>
+            <a:ext cx="5486400" cy="320040"/>
+          </a:xfrm>
+          <a:prstGeom prst="rect">
+            <a:avLst/>
+          </a:prstGeom>
+          <a:noFill/>
+          <a:ln/>
+        </p:spPr>
+        <p:txBody>
+          <a:bodyPr wrap="square" lIns="0" tIns="0" rIns="0" bIns="0" rtlCol="0" anchor="ctr"/>
+          <a:lstStyle/>
+          <a:p>
+            <a:pPr indent="0" marL="0">
+              <a:buNone/>
+            </a:pPr>
+            <a:r>
+              <a:rPr lang="en-US" sz="1400" dirty="0">
+                <a:solidFill>
+                  <a:srgbClr val="06D6A0"/>
+                </a:solidFill>
+                <a:latin typeface="Calibri" pitchFamily="34" charset="0"/>
+                <a:ea typeface="Calibri" pitchFamily="34" charset="-122"/>
+                <a:cs typeface="Calibri" pitchFamily="34" charset="-120"/>
+              </a:rPr>
+              <a:t>Project HK-UHI10-1050</a:t>
+            </a:r>
+            <a:endParaRPr lang="en-US" sz="1400" dirty="0"/>
+          </a:p>
+        </p:txBody>
+      </p:sp>
+      <p:sp>
+        <p:nvSpPr>
+          <p:cNvPr id="4" name="Shape 2"/>
+          <p:cNvSpPr/>
+          <p:nvPr/>
+        </p:nvSpPr>
+        <p:spPr>
+          <a:xfrm>
+            <a:off x="640080" y="2011680"/>
+            <a:ext cx="10881360" cy="1143000"/>
+          </a:xfrm>
+          <a:prstGeom prst="roundRect">
+            <a:avLst>
+              <a:gd name="adj" fmla="val 6400"/>
+            </a:avLst>
+          </a:prstGeom>
+          <a:solidFill>
+            <a:srgbClr val="213341"/>
+          </a:solidFill>
+          <a:ln w="12700">
+            <a:solidFill>
+              <a:srgbClr val="213341"/>
+            </a:solidFill>
+            <a:prstDash val="solid"/>
+          </a:ln>
+        </p:spPr>
+      </p:sp>
+      <p:sp>
+        <p:nvSpPr>
+          <p:cNvPr id="5" name="Text 3"/>
+          <p:cNvSpPr txBox="1"/>
+          <p:nvPr/>
+        </p:nvSpPr>
+        <p:spPr>
+          <a:xfrm>
+            <a:off x="960120" y="2194560"/>
+            <a:ext cx="3657600" cy="274320"/>
+          </a:xfrm>
+          <a:prstGeom prst="rect">
+            <a:avLst/>
+          </a:prstGeom>
+          <a:noFill/>
+          <a:ln/>
+        </p:spPr>
+        <p:txBody>
+          <a:bodyPr wrap="square" lIns="0" tIns="0" rIns="0" bIns="0" rtlCol="0" anchor="ctr"/>
+          <a:lstStyle/>
+          <a:p>
+            <a:pPr indent="0" marL="0">
+              <a:buNone/>
+            </a:pPr>
+            <a:r>
+              <a:rPr lang="en-US" sz="1300" dirty="0">
+                <a:solidFill>
+                  <a:srgbClr val="8FA3B0"/>
+                </a:solidFill>
+                <a:latin typeface="Calibri" pitchFamily="34" charset="0"/>
+                <a:ea typeface="Calibri" pitchFamily="34" charset="-122"/>
+                <a:cs typeface="Calibri" pitchFamily="34" charset="-120"/>
+              </a:rPr>
+              <a:t>Repository</a:t>
+            </a:r>
+            <a:endParaRPr lang="en-US" sz="1300" dirty="0"/>
+          </a:p>
+        </p:txBody>
+      </p:sp>
+      <p:sp>
+        <p:nvSpPr>
+          <p:cNvPr id="6" name="Text 4"/>
+          <p:cNvSpPr txBox="1"/>
+          <p:nvPr/>
+        </p:nvSpPr>
+        <p:spPr>
+          <a:xfrm>
+            <a:off x="960120" y="2468880"/>
+            <a:ext cx="7772400" cy="411480"/>
+          </a:xfrm>
+          <a:prstGeom prst="rect">
+            <a:avLst/>
+          </a:prstGeom>
+          <a:noFill/>
+          <a:ln/>
+        </p:spPr>
+        <p:txBody>
+          <a:bodyPr wrap="square" lIns="0" tIns="0" rIns="0" bIns="0" rtlCol="0" anchor="ctr"/>
+          <a:lstStyle/>
+          <a:p>
+            <a:pPr indent="0" marL="0">
+              <a:buNone/>
+            </a:pPr>
+            <a:r>
+              <a:rPr lang="en-US" sz="2100" b="1" dirty="0">
+                <a:solidFill>
+                  <a:srgbClr val="06D6A0"/>
+                </a:solidFill>
+                <a:latin typeface="Courier New" pitchFamily="34" charset="0"/>
+                <a:ea typeface="Courier New" pitchFamily="34" charset="-122"/>
+                <a:cs typeface="Courier New" pitchFamily="34" charset="-120"/>
+              </a:rPr>
+              <a:t>github.com/sivajialla/gradient-shield</a:t>
+            </a:r>
+            <a:endParaRPr lang="en-US" sz="2100" dirty="0"/>
+          </a:p>
+        </p:txBody>
+      </p:sp>
+      <p:sp>
+        <p:nvSpPr>
+          <p:cNvPr id="7" name="Text 5"/>
+          <p:cNvSpPr txBox="1"/>
+          <p:nvPr/>
+        </p:nvSpPr>
+        <p:spPr>
+          <a:xfrm>
+            <a:off x="9052560" y="2542032"/>
+            <a:ext cx="2194560" cy="320040"/>
+          </a:xfrm>
+          <a:prstGeom prst="rect">
+            <a:avLst/>
+          </a:prstGeom>
+          <a:noFill/>
+          <a:ln/>
+        </p:spPr>
+        <p:txBody>
+          <a:bodyPr wrap="square" lIns="0" tIns="0" rIns="0" bIns="0" rtlCol="0" anchor="ctr"/>
+          <a:lstStyle/>
+          <a:p>
+            <a:pPr algn="r" indent="0" marL="0">
+              <a:buNone/>
+            </a:pPr>
+            <a:r>
+              <a:rPr lang="en-US" sz="1300" dirty="0">
+                <a:solidFill>
+                  <a:srgbClr val="5D717E"/>
+                </a:solidFill>
+                <a:latin typeface="Calibri" pitchFamily="34" charset="0"/>
+                <a:ea typeface="Calibri" pitchFamily="34" charset="-122"/>
+                <a:cs typeface="Calibri" pitchFamily="34" charset="-120"/>
+              </a:rPr>
+              <a:t>MIT licensed</a:t>
+            </a:r>
+            <a:endParaRPr lang="en-US" sz="1300" dirty="0"/>
+          </a:p>
+        </p:txBody>
+      </p:sp>
+      <p:sp>
+        <p:nvSpPr>
+          <p:cNvPr id="8" name="Shape 6"/>
+          <p:cNvSpPr/>
+          <p:nvPr/>
+        </p:nvSpPr>
+        <p:spPr>
+          <a:xfrm>
+            <a:off x="640080" y="3337560"/>
+            <a:ext cx="5669280" cy="1417320"/>
+          </a:xfrm>
+          <a:prstGeom prst="roundRect">
+            <a:avLst>
+              <a:gd name="adj" fmla="val 5161"/>
+            </a:avLst>
+          </a:prstGeom>
+          <a:solidFill>
+            <a:srgbClr val="1B2A36"/>
+          </a:solidFill>
+          <a:ln w="12700">
+            <a:solidFill>
+              <a:srgbClr val="1B2A36"/>
+            </a:solidFill>
+            <a:prstDash val="solid"/>
+          </a:ln>
+        </p:spPr>
+      </p:sp>
+      <p:sp>
+        <p:nvSpPr>
+          <p:cNvPr id="9" name="Text 7"/>
+          <p:cNvSpPr txBox="1"/>
+          <p:nvPr/>
+        </p:nvSpPr>
+        <p:spPr>
+          <a:xfrm>
+            <a:off x="914400" y="3520440"/>
+            <a:ext cx="5029200" cy="274320"/>
+          </a:xfrm>
+          <a:prstGeom prst="rect">
+            <a:avLst/>
+          </a:prstGeom>
+          <a:noFill/>
+          <a:ln/>
+        </p:spPr>
+        <p:txBody>
+          <a:bodyPr wrap="square" lIns="0" tIns="0" rIns="0" bIns="0" rtlCol="0" anchor="ctr"/>
+          <a:lstStyle/>
+          <a:p>
+            <a:pPr indent="0" marL="0">
+              <a:buNone/>
+            </a:pPr>
+            <a:r>
+              <a:rPr lang="en-US" sz="1400" b="1" dirty="0">
+                <a:solidFill>
+                  <a:srgbClr val="EAF2F6"/>
+                </a:solidFill>
+                <a:latin typeface="Arial" pitchFamily="34" charset="0"/>
+                <a:ea typeface="Arial" pitchFamily="34" charset="-122"/>
+                <a:cs typeface="Arial" pitchFamily="34" charset="-120"/>
+              </a:rPr>
+              <a:t>Verify in one command</a:t>
+            </a:r>
+            <a:endParaRPr lang="en-US" sz="1400" dirty="0"/>
+          </a:p>
+        </p:txBody>
+      </p:sp>
+      <p:sp>
+        <p:nvSpPr>
+          <p:cNvPr id="10" name="Text 8"/>
+          <p:cNvSpPr txBox="1"/>
+          <p:nvPr/>
+        </p:nvSpPr>
+        <p:spPr>
+          <a:xfrm>
+            <a:off x="914400" y="3840480"/>
+            <a:ext cx="5120640" cy="548640"/>
+          </a:xfrm>
+          <a:prstGeom prst="rect">
+            <a:avLst/>
+          </a:prstGeom>
+          <a:noFill/>
+          <a:ln/>
+        </p:spPr>
+        <p:txBody>
+          <a:bodyPr wrap="square" lIns="0" tIns="0" rIns="0" bIns="0" rtlCol="0" anchor="ctr"/>
+          <a:lstStyle/>
+          <a:p>
+            <a:pPr indent="0" marL="0">
+              <a:lnSpc>
+                <a:spcPts val="1700"/>
+              </a:lnSpc>
+              <a:buNone/>
+            </a:pPr>
+            <a:r>
+              <a:rPr lang="en-US" sz="1200" dirty="0">
+                <a:solidFill>
+                  <a:srgbClr val="FFC15E"/>
+                </a:solidFill>
+                <a:latin typeface="Courier New" pitchFamily="34" charset="0"/>
+                <a:ea typeface="Courier New" pitchFamily="34" charset="-122"/>
+                <a:cs typeface="Courier New" pitchFamily="34" charset="-120"/>
+              </a:rPr>
+              <a:t>git clone --recurse-submodules &lt;repo&gt;</a:t>
+            </a:r>
+            <a:endParaRPr lang="en-US" sz="1200" dirty="0"/>
+          </a:p>
+          <a:p>
+            <a:pPr indent="0" marL="0">
+              <a:lnSpc>
+                <a:spcPts val="1700"/>
+              </a:lnSpc>
+              <a:buNone/>
+            </a:pPr>
+            <a:r>
+              <a:rPr lang="en-US" sz="1200" dirty="0">
+                <a:solidFill>
+                  <a:srgbClr val="FFC15E"/>
+                </a:solidFill>
+                <a:latin typeface="Courier New" pitchFamily="34" charset="0"/>
+                <a:ea typeface="Courier New" pitchFamily="34" charset="-122"/>
+                <a:cs typeface="Courier New" pitchFamily="34" charset="-120"/>
+              </a:rPr>
+              <a:t>forge test</a:t>
+            </a:r>
+            <a:endParaRPr lang="en-US" sz="1200" dirty="0"/>
+          </a:p>
+        </p:txBody>
+      </p:sp>
+      <p:sp>
+        <p:nvSpPr>
+          <p:cNvPr id="11" name="Text 9"/>
+          <p:cNvSpPr txBox="1"/>
+          <p:nvPr/>
+        </p:nvSpPr>
+        <p:spPr>
+          <a:xfrm>
+            <a:off x="914400" y="4407408"/>
+            <a:ext cx="5029200" cy="256032"/>
+          </a:xfrm>
+          <a:prstGeom prst="rect">
+            <a:avLst/>
+          </a:prstGeom>
+          <a:noFill/>
+          <a:ln/>
+        </p:spPr>
+        <p:txBody>
+          <a:bodyPr wrap="square" lIns="0" tIns="0" rIns="0" bIns="0" rtlCol="0" anchor="ctr"/>
+          <a:lstStyle/>
+          <a:p>
+            <a:pPr indent="0" marL="0">
+              <a:buNone/>
+            </a:pPr>
+            <a:r>
+              <a:rPr lang="en-US" sz="1200" dirty="0">
+                <a:solidFill>
+                  <a:srgbClr val="06D6A0"/>
+                </a:solidFill>
+                <a:latin typeface="Calibri" pitchFamily="34" charset="0"/>
+                <a:ea typeface="Calibri" pitchFamily="34" charset="-122"/>
+                <a:cs typeface="Calibri" pitchFamily="34" charset="-120"/>
+              </a:rPr>
+              <a:t>247 passing, no further setup</a:t>
+            </a:r>
+            <a:endParaRPr lang="en-US" sz="1200" dirty="0"/>
+          </a:p>
+        </p:txBody>
+      </p:sp>
+      <p:sp>
+        <p:nvSpPr>
+          <p:cNvPr id="12" name="Shape 10"/>
+          <p:cNvSpPr/>
+          <p:nvPr/>
+        </p:nvSpPr>
+        <p:spPr>
+          <a:xfrm>
+            <a:off x="6675120" y="3337560"/>
+            <a:ext cx="4572000" cy="1417320"/>
+          </a:xfrm>
+          <a:prstGeom prst="roundRect">
+            <a:avLst>
+              <a:gd name="adj" fmla="val 5161"/>
+            </a:avLst>
+          </a:prstGeom>
+          <a:solidFill>
+            <a:srgbClr val="1B2A36"/>
+          </a:solidFill>
+          <a:ln w="12700">
+            <a:solidFill>
+              <a:srgbClr val="1B2A36"/>
+            </a:solidFill>
+            <a:prstDash val="solid"/>
+          </a:ln>
+        </p:spPr>
+      </p:sp>
+      <p:sp>
+        <p:nvSpPr>
+          <p:cNvPr id="13" name="Text 11"/>
+          <p:cNvSpPr txBox="1"/>
+          <p:nvPr/>
+        </p:nvSpPr>
+        <p:spPr>
+          <a:xfrm>
+            <a:off x="6949440" y="3520440"/>
+            <a:ext cx="4023360" cy="274320"/>
+          </a:xfrm>
+          <a:prstGeom prst="rect">
+            <a:avLst/>
+          </a:prstGeom>
+          <a:noFill/>
+          <a:ln/>
+        </p:spPr>
+        <p:txBody>
+          <a:bodyPr wrap="square" lIns="0" tIns="0" rIns="0" bIns="0" rtlCol="0" anchor="ctr"/>
+          <a:lstStyle/>
+          <a:p>
+            <a:pPr indent="0" marL="0">
+              <a:buNone/>
+            </a:pPr>
+            <a:r>
+              <a:rPr lang="en-US" sz="1400" b="1" dirty="0">
+                <a:solidFill>
+                  <a:srgbClr val="EAF2F6"/>
+                </a:solidFill>
+                <a:latin typeface="Arial" pitchFamily="34" charset="0"/>
+                <a:ea typeface="Arial" pitchFamily="34" charset="-122"/>
+                <a:cs typeface="Arial" pitchFamily="34" charset="-120"/>
+              </a:rPr>
+              <a:t>What is in it</a:t>
+            </a:r>
+            <a:endParaRPr lang="en-US" sz="1400" dirty="0"/>
+          </a:p>
+        </p:txBody>
+      </p:sp>
+      <p:sp>
+        <p:nvSpPr>
+          <p:cNvPr id="14" name="Text 12"/>
+          <p:cNvSpPr txBox="1"/>
+          <p:nvPr/>
+        </p:nvSpPr>
+        <p:spPr>
+          <a:xfrm>
+            <a:off x="6949440" y="3858768"/>
+            <a:ext cx="2834640" cy="256032"/>
+          </a:xfrm>
+          <a:prstGeom prst="rect">
+            <a:avLst/>
+          </a:prstGeom>
+          <a:noFill/>
+          <a:ln/>
+        </p:spPr>
+        <p:txBody>
+          <a:bodyPr wrap="square" lIns="0" tIns="0" rIns="0" bIns="0" rtlCol="0" anchor="ctr"/>
+          <a:lstStyle/>
+          <a:p>
+            <a:pPr indent="0" marL="0">
+              <a:buNone/>
+            </a:pPr>
+            <a:r>
+              <a:rPr lang="en-US" sz="1200" dirty="0">
+                <a:solidFill>
+                  <a:srgbClr val="8FA3B0"/>
+                </a:solidFill>
+                <a:latin typeface="Calibri" pitchFamily="34" charset="0"/>
+                <a:ea typeface="Calibri" pitchFamily="34" charset="-122"/>
+                <a:cs typeface="Calibri" pitchFamily="34" charset="-120"/>
+              </a:rPr>
+              <a:t>Uniswap v4 hook</a:t>
+            </a:r>
+            <a:endParaRPr lang="en-US" sz="1200" dirty="0"/>
+          </a:p>
+        </p:txBody>
+      </p:sp>
+      <p:sp>
+        <p:nvSpPr>
+          <p:cNvPr id="15" name="Text 13"/>
+          <p:cNvSpPr txBox="1"/>
+          <p:nvPr/>
+        </p:nvSpPr>
+        <p:spPr>
+          <a:xfrm>
+            <a:off x="9784080" y="3858768"/>
+            <a:ext cx="1188720" cy="256032"/>
+          </a:xfrm>
+          <a:prstGeom prst="rect">
+            <a:avLst/>
+          </a:prstGeom>
+          <a:noFill/>
+          <a:ln/>
+        </p:spPr>
+        <p:txBody>
+          <a:bodyPr wrap="square" lIns="0" tIns="0" rIns="0" bIns="0" rtlCol="0" anchor="ctr"/>
+          <a:lstStyle/>
+          <a:p>
+            <a:pPr algn="r" indent="0" marL="0">
+              <a:buNone/>
+            </a:pPr>
+            <a:r>
+              <a:rPr lang="en-US" sz="1200" b="1" dirty="0">
+                <a:solidFill>
+                  <a:srgbClr val="FFC15E"/>
+                </a:solidFill>
+                <a:latin typeface="Courier New" pitchFamily="34" charset="0"/>
+                <a:ea typeface="Courier New" pitchFamily="34" charset="-122"/>
+                <a:cs typeface="Courier New" pitchFamily="34" charset="-120"/>
+              </a:rPr>
+              <a:t>12.8 KB</a:t>
+            </a:r>
+            <a:endParaRPr lang="en-US" sz="1200" dirty="0"/>
+          </a:p>
+        </p:txBody>
+      </p:sp>
+      <p:sp>
+        <p:nvSpPr>
+          <p:cNvPr id="16" name="Text 14"/>
+          <p:cNvSpPr txBox="1"/>
+          <p:nvPr/>
+        </p:nvSpPr>
+        <p:spPr>
+          <a:xfrm>
+            <a:off x="6949440" y="4142232"/>
+            <a:ext cx="2834640" cy="256032"/>
+          </a:xfrm>
+          <a:prstGeom prst="rect">
+            <a:avLst/>
+          </a:prstGeom>
+          <a:noFill/>
+          <a:ln/>
+        </p:spPr>
+        <p:txBody>
+          <a:bodyPr wrap="square" lIns="0" tIns="0" rIns="0" bIns="0" rtlCol="0" anchor="ctr"/>
+          <a:lstStyle/>
+          <a:p>
+            <a:pPr indent="0" marL="0">
+              <a:buNone/>
+            </a:pPr>
+            <a:r>
+              <a:rPr lang="en-US" sz="1200" dirty="0">
+                <a:solidFill>
+                  <a:srgbClr val="8FA3B0"/>
+                </a:solidFill>
+                <a:latin typeface="Calibri" pitchFamily="34" charset="0"/>
+                <a:ea typeface="Calibri" pitchFamily="34" charset="-122"/>
+                <a:cs typeface="Calibri" pitchFamily="34" charset="-120"/>
+              </a:rPr>
+              <a:t>BLS quorum AVS</a:t>
+            </a:r>
+            <a:endParaRPr lang="en-US" sz="1200" dirty="0"/>
+          </a:p>
+        </p:txBody>
+      </p:sp>
+      <p:sp>
+        <p:nvSpPr>
+          <p:cNvPr id="17" name="Text 15"/>
+          <p:cNvSpPr txBox="1"/>
+          <p:nvPr/>
+        </p:nvSpPr>
+        <p:spPr>
+          <a:xfrm>
+            <a:off x="9784080" y="4142232"/>
+            <a:ext cx="1188720" cy="256032"/>
+          </a:xfrm>
+          <a:prstGeom prst="rect">
+            <a:avLst/>
+          </a:prstGeom>
+          <a:noFill/>
+          <a:ln/>
+        </p:spPr>
+        <p:txBody>
+          <a:bodyPr wrap="square" lIns="0" tIns="0" rIns="0" bIns="0" rtlCol="0" anchor="ctr"/>
+          <a:lstStyle/>
+          <a:p>
+            <a:pPr algn="r" indent="0" marL="0">
+              <a:buNone/>
+            </a:pPr>
+            <a:r>
+              <a:rPr lang="en-US" sz="1200" b="1" dirty="0">
+                <a:solidFill>
+                  <a:srgbClr val="FFC15E"/>
+                </a:solidFill>
+                <a:latin typeface="Courier New" pitchFamily="34" charset="0"/>
+                <a:ea typeface="Courier New" pitchFamily="34" charset="-122"/>
+                <a:cs typeface="Courier New" pitchFamily="34" charset="-120"/>
+              </a:rPr>
+              <a:t>BN254</a:t>
+            </a:r>
+            <a:endParaRPr lang="en-US" sz="1200" dirty="0"/>
+          </a:p>
+        </p:txBody>
+      </p:sp>
+      <p:sp>
+        <p:nvSpPr>
+          <p:cNvPr id="18" name="Text 16"/>
+          <p:cNvSpPr txBox="1"/>
+          <p:nvPr/>
+        </p:nvSpPr>
+        <p:spPr>
+          <a:xfrm>
+            <a:off x="6949440" y="4425696"/>
+            <a:ext cx="2834640" cy="256032"/>
+          </a:xfrm>
+          <a:prstGeom prst="rect">
+            <a:avLst/>
+          </a:prstGeom>
+          <a:noFill/>
+          <a:ln/>
+        </p:spPr>
+        <p:txBody>
+          <a:bodyPr wrap="square" lIns="0" tIns="0" rIns="0" bIns="0" rtlCol="0" anchor="ctr"/>
+          <a:lstStyle/>
+          <a:p>
+            <a:pPr indent="0" marL="0">
+              <a:buNone/>
+            </a:pPr>
+            <a:r>
+              <a:rPr lang="en-US" sz="1200" dirty="0">
+                <a:solidFill>
+                  <a:srgbClr val="8FA3B0"/>
+                </a:solidFill>
+                <a:latin typeface="Calibri" pitchFamily="34" charset="0"/>
+                <a:ea typeface="Calibri" pitchFamily="34" charset="-122"/>
+                <a:cs typeface="Calibri" pitchFamily="34" charset="-120"/>
+              </a:rPr>
+              <a:t>Live demo</a:t>
+            </a:r>
+            <a:endParaRPr lang="en-US" sz="1200" dirty="0"/>
+          </a:p>
+        </p:txBody>
+      </p:sp>
+      <p:sp>
+        <p:nvSpPr>
+          <p:cNvPr id="19" name="Text 17"/>
+          <p:cNvSpPr txBox="1"/>
+          <p:nvPr/>
+        </p:nvSpPr>
+        <p:spPr>
+          <a:xfrm>
+            <a:off x="9784080" y="4425696"/>
+            <a:ext cx="1188720" cy="256032"/>
+          </a:xfrm>
+          <a:prstGeom prst="rect">
+            <a:avLst/>
+          </a:prstGeom>
+          <a:noFill/>
+          <a:ln/>
+        </p:spPr>
+        <p:txBody>
+          <a:bodyPr wrap="square" lIns="0" tIns="0" rIns="0" bIns="0" rtlCol="0" anchor="ctr"/>
+          <a:lstStyle/>
+          <a:p>
+            <a:pPr algn="r" indent="0" marL="0">
+              <a:buNone/>
+            </a:pPr>
+            <a:r>
+              <a:rPr lang="en-US" sz="1200" b="1" dirty="0">
+                <a:solidFill>
+                  <a:srgbClr val="FFC15E"/>
+                </a:solidFill>
+                <a:latin typeface="Courier New" pitchFamily="34" charset="0"/>
+                <a:ea typeface="Courier New" pitchFamily="34" charset="-122"/>
+                <a:cs typeface="Courier New" pitchFamily="34" charset="-120"/>
+              </a:rPr>
+              <a:t>4 commands</a:t>
+            </a:r>
+            <a:endParaRPr lang="en-US" sz="1200" dirty="0"/>
+          </a:p>
+        </p:txBody>
+      </p:sp>
+      <p:sp>
+        <p:nvSpPr>
+          <p:cNvPr id="20" name="Shape 18"/>
+          <p:cNvSpPr/>
+          <p:nvPr/>
+        </p:nvSpPr>
+        <p:spPr>
+          <a:xfrm>
+            <a:off x="640080" y="4937760"/>
+            <a:ext cx="10881360" cy="1234440"/>
+          </a:xfrm>
+          <a:prstGeom prst="roundRect">
+            <a:avLst>
+              <a:gd name="adj" fmla="val 5926"/>
+            </a:avLst>
+          </a:prstGeom>
+          <a:solidFill>
+            <a:srgbClr val="213341"/>
+          </a:solidFill>
+          <a:ln w="12700">
+            <a:solidFill>
+              <a:srgbClr val="213341"/>
+            </a:solidFill>
+            <a:prstDash val="solid"/>
+          </a:ln>
+        </p:spPr>
+      </p:sp>
+      <p:sp>
+        <p:nvSpPr>
+          <p:cNvPr id="21" name="Text 19"/>
+          <p:cNvSpPr txBox="1"/>
+          <p:nvPr/>
+        </p:nvSpPr>
+        <p:spPr>
+          <a:xfrm>
+            <a:off x="960120" y="5120640"/>
+            <a:ext cx="4937760" cy="274320"/>
+          </a:xfrm>
+          <a:prstGeom prst="rect">
+            <a:avLst/>
+          </a:prstGeom>
+          <a:noFill/>
+          <a:ln/>
+        </p:spPr>
+        <p:txBody>
+          <a:bodyPr wrap="square" lIns="0" tIns="0" rIns="0" bIns="0" rtlCol="0" anchor="ctr"/>
+          <a:lstStyle/>
+          <a:p>
+            <a:pPr indent="0" marL="0">
+              <a:buNone/>
+            </a:pPr>
+            <a:r>
+              <a:rPr lang="en-US" sz="1500" b="1" dirty="0">
+                <a:solidFill>
+                  <a:srgbClr val="06D6A0"/>
+                </a:solidFill>
+                <a:latin typeface="Arial" pitchFamily="34" charset="0"/>
+                <a:ea typeface="Arial" pitchFamily="34" charset="-122"/>
+                <a:cs typeface="Arial" pitchFamily="34" charset="-120"/>
+              </a:rPr>
+              <a:t>MEV protection</a:t>
+            </a:r>
+            <a:endParaRPr lang="en-US" sz="1500" dirty="0"/>
+          </a:p>
+        </p:txBody>
+      </p:sp>
+      <p:sp>
+        <p:nvSpPr>
+          <p:cNvPr id="22" name="Text 20"/>
+          <p:cNvSpPr txBox="1"/>
+          <p:nvPr/>
+        </p:nvSpPr>
+        <p:spPr>
+          <a:xfrm>
+            <a:off x="960120" y="5413248"/>
+            <a:ext cx="4937760" cy="548640"/>
+          </a:xfrm>
+          <a:prstGeom prst="rect">
+            <a:avLst/>
+          </a:prstGeom>
+          <a:noFill/>
+          <a:ln/>
+        </p:spPr>
+        <p:txBody>
+          <a:bodyPr wrap="square" lIns="0" tIns="0" rIns="0" bIns="0" rtlCol="0" anchor="ctr"/>
+          <a:lstStyle/>
+          <a:p>
+            <a:pPr indent="0" marL="0">
+              <a:lnSpc>
+                <a:spcPts val="1600"/>
+              </a:lnSpc>
+              <a:buNone/>
+            </a:pPr>
+            <a:r>
+              <a:rPr lang="en-US" sz="1200" dirty="0">
+                <a:solidFill>
+                  <a:srgbClr val="8FA3B0"/>
+                </a:solidFill>
+                <a:latin typeface="Calibri" pitchFamily="34" charset="0"/>
+                <a:ea typeface="Calibri" pitchFamily="34" charset="-122"/>
+                <a:cs typeface="Calibri" pitchFamily="34" charset="-120"/>
+              </a:rPr>
+              <a:t>Sandwich and JIT priced out on the first trade; the attacker pays 5.3x.</a:t>
+            </a:r>
+            <a:endParaRPr lang="en-US" sz="1200" dirty="0"/>
+          </a:p>
+        </p:txBody>
+      </p:sp>
+      <p:sp>
+        <p:nvSpPr>
+          <p:cNvPr id="23" name="Text 21"/>
+          <p:cNvSpPr txBox="1"/>
+          <p:nvPr/>
+        </p:nvSpPr>
+        <p:spPr>
+          <a:xfrm>
+            <a:off x="6309360" y="5120640"/>
+            <a:ext cx="4937760" cy="274320"/>
+          </a:xfrm>
+          <a:prstGeom prst="rect">
+            <a:avLst/>
+          </a:prstGeom>
+          <a:noFill/>
+          <a:ln/>
+        </p:spPr>
+        <p:txBody>
+          <a:bodyPr wrap="square" lIns="0" tIns="0" rIns="0" bIns="0" rtlCol="0" anchor="ctr"/>
+          <a:lstStyle/>
+          <a:p>
+            <a:pPr indent="0" marL="0">
+              <a:buNone/>
+            </a:pPr>
+            <a:r>
+              <a:rPr lang="en-US" sz="1500" b="1" dirty="0">
+                <a:solidFill>
+                  <a:srgbClr val="06D6A0"/>
+                </a:solidFill>
+                <a:latin typeface="Arial" pitchFamily="34" charset="0"/>
+                <a:ea typeface="Arial" pitchFamily="34" charset="-122"/>
+                <a:cs typeface="Arial" pitchFamily="34" charset="-120"/>
+              </a:rPr>
+              <a:t>Sustainable liquidity</a:t>
+            </a:r>
+            <a:endParaRPr lang="en-US" sz="1500" dirty="0"/>
+          </a:p>
+        </p:txBody>
+      </p:sp>
+      <p:sp>
+        <p:nvSpPr>
+          <p:cNvPr id="24" name="Text 22"/>
+          <p:cNvSpPr txBox="1"/>
+          <p:nvPr/>
+        </p:nvSpPr>
+        <p:spPr>
+          <a:xfrm>
+            <a:off x="6309360" y="5413248"/>
+            <a:ext cx="4937760" cy="548640"/>
+          </a:xfrm>
+          <a:prstGeom prst="rect">
+            <a:avLst/>
+          </a:prstGeom>
+          <a:noFill/>
+          <a:ln/>
+        </p:spPr>
+        <p:txBody>
+          <a:bodyPr wrap="square" lIns="0" tIns="0" rIns="0" bIns="0" rtlCol="0" anchor="ctr"/>
+          <a:lstStyle/>
+          <a:p>
+            <a:pPr indent="0" marL="0">
+              <a:lnSpc>
+                <a:spcPts val="1600"/>
+              </a:lnSpc>
+              <a:buNone/>
+            </a:pPr>
+            <a:r>
+              <a:rPr lang="en-US" sz="1200" dirty="0">
+                <a:solidFill>
+                  <a:srgbClr val="8FA3B0"/>
+                </a:solidFill>
+                <a:latin typeface="Calibri" pitchFamily="34" charset="0"/>
+                <a:ea typeface="Calibri" pitchFamily="34" charset="-122"/>
+                <a:cs typeface="Calibri" pitchFamily="34" charset="-120"/>
+              </a:rPr>
+              <a:t>The penalty is an LP fee, so extraction is redirected into LP yield.</a:t>
+            </a:r>
+            <a:endParaRPr lang="en-US" sz="1200" dirty="0"/>
+          </a:p>
+        </p:txBody>
+      </p:sp>
+    </p:spTree>
+  </p:cSld>
+  <p:clrMapOvr>
+    <a:masterClrMapping/>
+  </p:clrMapOvr>
+</p:sld>
+</file>
+
 <file path=ppt/slides/slide2.xml><?xml version="1.0" encoding="utf-8"?>
 <p:sld xmlns:a="http://schemas.openxmlformats.org/drawingml/2006/main" xmlns:r="http://schemas.openxmlformats.org/officeDocument/2006/relationships" xmlns:p="http://schemas.openxmlformats.org/presentationml/2006/main">
   <p:cSld name="Slide 2">

</xml_diff>

<commit_message>
Add author name to the title slide
Sivaji Alla, above the project number. Stat row ends at 6.25in, name sits at
6.45-6.77, project number at 6.78-7.08 — clear of each other and of the
7.5in slide edge.

Co-Authored-By: Claude Opus 4.6 <noreply@anthropic.com>
</commit_message>
<xml_diff>
--- a/GradientShield-Demo.pptx
+++ b/GradientShield-Demo.pptx
@@ -2327,7 +2327,46 @@
         </p:nvSpPr>
         <p:spPr>
           <a:xfrm>
-            <a:off x="640080" y="5989320"/>
+            <a:off x="640080" y="5897880"/>
+            <a:ext cx="5486400" cy="292608"/>
+          </a:xfrm>
+          <a:prstGeom prst="rect">
+            <a:avLst/>
+          </a:prstGeom>
+          <a:noFill/>
+          <a:ln/>
+        </p:spPr>
+        <p:txBody>
+          <a:bodyPr wrap="square" lIns="0" tIns="0" rIns="0" bIns="0" rtlCol="0" anchor="ctr"/>
+          <a:lstStyle/>
+          <a:p>
+            <a:pPr indent="0" marL="0">
+              <a:buNone/>
+            </a:pPr>
+            <a:r>
+              <a:rPr lang="en-US" sz="1500" b="1" dirty="0">
+                <a:solidFill>
+                  <a:srgbClr val="EAF2F6"/>
+                </a:solidFill>
+                <a:latin typeface="Arial" pitchFamily="34" charset="0"/>
+                <a:ea typeface="Arial" pitchFamily="34" charset="-122"/>
+                <a:cs typeface="Arial" pitchFamily="34" charset="-120"/>
+              </a:rPr>
+              <a:t>Sivaji Alla</a:t>
+            </a:r>
+            <a:endParaRPr lang="en-US" sz="1500" dirty="0"/>
+          </a:p>
+        </p:txBody>
+      </p:sp>
+      <p:sp>
+        <p:nvSpPr>
+          <p:cNvPr id="12" name="Text 10"/>
+          <p:cNvSpPr txBox="1"/>
+          <p:nvPr/>
+        </p:nvSpPr>
+        <p:spPr>
+          <a:xfrm>
+            <a:off x="640080" y="6199632"/>
             <a:ext cx="5486400" cy="274320"/>
           </a:xfrm>
           <a:prstGeom prst="rect">

</xml_diff>

<commit_message>
Add author email beside the name on the title slide
Name and email share a row (0.70-2.60 and 2.70-7.20 horizontally, both
6.45-6.77 vertically), project number below at 6.78-7.08. No overlap.

Co-Authored-By: Claude Opus 4.6 <noreply@anthropic.com>
</commit_message>
<xml_diff>
--- a/GradientShield-Demo.pptx
+++ b/GradientShield-Demo.pptx
@@ -2328,7 +2328,7 @@
         <p:spPr>
           <a:xfrm>
             <a:off x="640080" y="5897880"/>
-            <a:ext cx="5486400" cy="292608"/>
+            <a:ext cx="1737360" cy="292608"/>
           </a:xfrm>
           <a:prstGeom prst="rect">
             <a:avLst/>
@@ -2361,6 +2361,45 @@
       <p:sp>
         <p:nvSpPr>
           <p:cNvPr id="12" name="Text 10"/>
+          <p:cNvSpPr txBox="1"/>
+          <p:nvPr/>
+        </p:nvSpPr>
+        <p:spPr>
+          <a:xfrm>
+            <a:off x="2468880" y="5897880"/>
+            <a:ext cx="4114800" cy="292608"/>
+          </a:xfrm>
+          <a:prstGeom prst="rect">
+            <a:avLst/>
+          </a:prstGeom>
+          <a:noFill/>
+          <a:ln/>
+        </p:spPr>
+        <p:txBody>
+          <a:bodyPr wrap="square" lIns="0" tIns="0" rIns="0" bIns="0" rtlCol="0" anchor="ctr"/>
+          <a:lstStyle/>
+          <a:p>
+            <a:pPr indent="0" marL="0">
+              <a:buNone/>
+            </a:pPr>
+            <a:r>
+              <a:rPr lang="en-US" sz="1200" dirty="0">
+                <a:solidFill>
+                  <a:srgbClr val="8FA3B0"/>
+                </a:solidFill>
+                <a:latin typeface="Calibri" pitchFamily="34" charset="0"/>
+                <a:ea typeface="Calibri" pitchFamily="34" charset="-122"/>
+                <a:cs typeface="Calibri" pitchFamily="34" charset="-120"/>
+              </a:rPr>
+              <a:t>sivajialla01@gmail.com</a:t>
+            </a:r>
+            <a:endParaRPr lang="en-US" sz="1200" dirty="0"/>
+          </a:p>
+        </p:txBody>
+      </p:sp>
+      <p:sp>
+        <p:nvSpPr>
+          <p:cNvPr id="13" name="Text 11"/>
           <p:cNvSpPr txBox="1"/>
           <p:nvPr/>
         </p:nvSpPr>

</xml_diff>

<commit_message>
Close the left gap on the economics slide by hiding the value axis
The chart frame sat flush at 0.70in, aligned with the slide title, but
PowerPoint rendered the value axis labels (0.0000 to 0.0600) inside that frame
before the plot area began. The bars therefore started roughly an inch right of
the title's left edge, reading as an unexplained gap.

The axis was redundant anyway: showValue already prints each bar's exact value
above it, so the labels duplicated the data while indenting the plot. Hidden the
value axis and dropped its gridlines; the plot now expands to the frame edge and
the bars line up under the title.

Verified in chart1.xml: valAx carries delete=1, no gridlines, data labels on.

Co-Authored-By: Claude Opus 4.6 <noreply@anthropic.com>
</commit_message>
<xml_diff>
--- a/GradientShield-Demo.pptx
+++ b/GradientShield-Demo.pptx
@@ -333,19 +333,8 @@
         <c:scaling>
           <c:orientation val="minMax"/>
         </c:scaling>
-        <c:delete val="0"/>
+        <c:delete val="1"/>
         <c:axPos val="l"/>
-        <c:majorGridlines>
-          <c:spPr>
-            <a:ln w="12700" cap="flat">
-              <a:solidFill>
-                <a:srgbClr val="213341"/>
-              </a:solidFill>
-              <a:prstDash val="solid"/>
-              <a:round/>
-            </a:ln>
-          </c:spPr>
-        </c:majorGridlines>
         <c:numFmt formatCode="General" sourceLinked="0"/>
         <c:majorTickMark val="out"/>
         <c:minorTickMark val="none"/>
@@ -364,9 +353,9 @@
           <a:lstStyle/>
           <a:p>
             <a:pPr>
-              <a:defRPr sz="1000" b="0" i="0" u="none" strike="noStrike">
-                <a:solidFill>
-                  <a:srgbClr val="8FA3B0"/>
+              <a:defRPr sz="1200" b="0" i="0" u="none" strike="noStrike">
+                <a:solidFill>
+                  <a:srgbClr val="000000"/>
                 </a:solidFill>
                 <a:latin typeface="Arial"/>
               </a:defRPr>

</xml_diff>